<commit_message>
[feature] Add Demo folder with report generator and updated presentation
Add executable, report generation script, and batch runner under Demo/,
and refresh presentation.pptx to reflect the current demo workflow.

Co-Authored-By: Claude Sonnet 5 <noreply@anthropic.com>
</commit_message>
<xml_diff>
--- a/presentation.pptx
+++ b/presentation.pptx
@@ -34,7 +34,7 @@
     <p:sldId id="317" r:id="rId25"/>
     <p:sldId id="260" r:id="rId26"/>
     <p:sldId id="320" r:id="rId27"/>
-    <p:sldId id="259" r:id="rId28"/>
+    <p:sldId id="322" r:id="rId28"/>
     <p:sldId id="318" r:id="rId29"/>
     <p:sldId id="292" r:id="rId30"/>
     <p:sldId id="293" r:id="rId31"/>
@@ -308,7 +308,7 @@
             <p14:sldId id="317"/>
             <p14:sldId id="260"/>
             <p14:sldId id="320"/>
-            <p14:sldId id="259"/>
+            <p14:sldId id="322"/>
             <p14:sldId id="318"/>
             <p14:sldId id="292"/>
             <p14:sldId id="293"/>
@@ -327,7 +327,7 @@
       <p15:sldGuideLst xmlns:p15="http://schemas.microsoft.com/office/powerpoint/2012/main"/>
     </p:ext>
     <p:ext uri="GoogleSlidesCustomDataVersion2">
-      <go:slidesCustomData xmlns="" xmlns:mc="http://schemas.openxmlformats.org/markup-compatibility/2006" xmlns:mv="urn:schemas-microsoft-com:mac:vml" xmlns:c="http://schemas.openxmlformats.org/drawingml/2006/chart" xmlns:dgm="http://schemas.openxmlformats.org/drawingml/2006/diagram" xmlns:o="urn:schemas-microsoft-com:office:office" xmlns:v="urn:schemas-microsoft-com:vml" xmlns:pvml="urn:schemas-microsoft-com:office:powerpoint" xmlns:com="http://schemas.openxmlformats.org/drawingml/2006/compatibility" xmlns:p14="http://schemas.microsoft.com/office/powerpoint/2010/main" xmlns:p15="http://schemas.microsoft.com/office/powerpoint/2012/main" xmlns:ahyp="http://schemas.microsoft.com/office/drawing/2018/hyperlinkcolor" xmlns:go="http://customooxmlschemas.google.com/" r:id="rId40" roundtripDataSignature="AMtx7mj5GdbxsaFl02bTEFBl/9s84/Z/Bw=="/>
+      <go:slidesCustomData xmlns:go="http://customooxmlschemas.google.com/" xmlns:ahyp="http://schemas.microsoft.com/office/drawing/2018/hyperlinkcolor" xmlns:p15="http://schemas.microsoft.com/office/powerpoint/2012/main" xmlns:p14="http://schemas.microsoft.com/office/powerpoint/2010/main" xmlns:com="http://schemas.openxmlformats.org/drawingml/2006/compatibility" xmlns:pvml="urn:schemas-microsoft-com:office:powerpoint" xmlns:v="urn:schemas-microsoft-com:vml" xmlns:o="urn:schemas-microsoft-com:office:office" xmlns:dgm="http://schemas.openxmlformats.org/drawingml/2006/diagram" xmlns:c="http://schemas.openxmlformats.org/drawingml/2006/chart" xmlns:mv="urn:schemas-microsoft-com:mac:vml" xmlns:mc="http://schemas.openxmlformats.org/markup-compatibility/2006" xmlns="" r:id="rId40" roundtripDataSignature="AMtx7mj5GdbxsaFl02bTEFBl/9s84/Z/Bw=="/>
     </p:ext>
   </p:extLst>
 </p:presentation>
@@ -891,7 +891,7 @@
   <p:cSld>
     <p:spTree>
       <p:nvGrpSpPr>
-        <p:cNvPr id="1" name="Shape 61"/>
+        <p:cNvPr id="1" name="Shape 50"/>
         <p:cNvGrpSpPr/>
         <p:nvPr/>
       </p:nvGrpSpPr>
@@ -905,7 +905,7 @@
       </p:grpSpPr>
       <p:sp>
         <p:nvSpPr>
-          <p:cNvPr id="62" name="Google Shape;62;p4:notes"/>
+          <p:cNvPr id="51" name="Google Shape;51;p2:notes"/>
           <p:cNvSpPr txBox="1">
             <a:spLocks noGrp="1"/>
           </p:cNvSpPr>
@@ -943,7 +943,7 @@
       </p:sp>
       <p:sp>
         <p:nvSpPr>
-          <p:cNvPr id="63" name="Google Shape;63;p4:notes"/>
+          <p:cNvPr id="52" name="Google Shape;52;p2:notes"/>
           <p:cNvSpPr>
             <a:spLocks noGrp="1" noRot="1" noChangeAspect="1"/>
           </p:cNvSpPr>
@@ -953,8 +953,8 @@
         </p:nvSpPr>
         <p:spPr>
           <a:xfrm>
-            <a:off x="1143225" y="685800"/>
-            <a:ext cx="4572225" cy="3429000"/>
+            <a:off x="381000" y="685800"/>
+            <a:ext cx="6096000" cy="3429000"/>
           </a:xfrm>
           <a:custGeom>
             <a:avLst/>
@@ -983,6 +983,11 @@
         </p:spPr>
       </p:sp>
     </p:spTree>
+    <p:extLst>
+      <p:ext uri="{BB962C8B-B14F-4D97-AF65-F5344CB8AC3E}">
+        <p14:creationId xmlns:p14="http://schemas.microsoft.com/office/powerpoint/2010/main" val="235167166"/>
+      </p:ext>
+    </p:extLst>
   </p:cSld>
   <p:clrMapOvr>
     <a:masterClrMapping/>
@@ -1670,7 +1675,7 @@
     </p:spTree>
     <p:extLst>
       <p:ext uri="{BB962C8B-B14F-4D97-AF65-F5344CB8AC3E}">
-        <p14:creationId xmlns:p14="http://schemas.microsoft.com/office/powerpoint/2010/main" val="2617793909"/>
+        <p14:creationId xmlns:p14="http://schemas.microsoft.com/office/powerpoint/2010/main" val="4016758491"/>
       </p:ext>
     </p:extLst>
   </p:cSld>
@@ -1736,7 +1741,7 @@
     </p:spTree>
     <p:extLst>
       <p:ext uri="{BB962C8B-B14F-4D97-AF65-F5344CB8AC3E}">
-        <p14:creationId xmlns:p14="http://schemas.microsoft.com/office/powerpoint/2010/main" val="1595947576"/>
+        <p14:creationId xmlns:p14="http://schemas.microsoft.com/office/powerpoint/2010/main" val="2617793909"/>
       </p:ext>
     </p:extLst>
   </p:cSld>
@@ -1747,11 +1752,11 @@
 </file>
 
 <file path=ppt/notesSlides/notesSlide8.xml><?xml version="1.0" encoding="utf-8"?>
-<p:notes xmlns:a="http://schemas.openxmlformats.org/drawingml/2006/main" xmlns:r="http://schemas.openxmlformats.org/officeDocument/2006/relationships" xmlns:p="http://schemas.openxmlformats.org/presentationml/2006/main" showMasterSp="0" showMasterPhAnim="0">
+<p:notes xmlns:a="http://schemas.openxmlformats.org/drawingml/2006/main" xmlns:r="http://schemas.openxmlformats.org/officeDocument/2006/relationships" xmlns:p="http://schemas.openxmlformats.org/presentationml/2006/main">
   <p:cSld>
     <p:spTree>
       <p:nvGrpSpPr>
-        <p:cNvPr id="1" name="Shape 50"/>
+        <p:cNvPr id="1" name=""/>
         <p:cNvGrpSpPr/>
         <p:nvPr/>
       </p:nvGrpSpPr>
@@ -1765,50 +1770,12 @@
       </p:grpSpPr>
       <p:sp>
         <p:nvSpPr>
-          <p:cNvPr id="51" name="Google Shape;51;p2:notes"/>
-          <p:cNvSpPr txBox="1">
-            <a:spLocks noGrp="1"/>
-          </p:cNvSpPr>
-          <p:nvPr>
-            <p:ph type="body" idx="1"/>
-          </p:nvPr>
-        </p:nvSpPr>
-        <p:spPr>
-          <a:xfrm>
-            <a:off x="685800" y="4343400"/>
-            <a:ext cx="5486400" cy="4114800"/>
-          </a:xfrm>
-          <a:prstGeom prst="rect">
-            <a:avLst/>
-          </a:prstGeom>
-        </p:spPr>
-        <p:txBody>
-          <a:bodyPr spcFirstLastPara="1" wrap="square" lIns="91425" tIns="91425" rIns="91425" bIns="91425" anchor="t" anchorCtr="0">
-            <a:noAutofit/>
-          </a:bodyPr>
-          <a:lstStyle/>
-          <a:p>
-            <a:pPr marL="0" lvl="0" indent="0" algn="l" rtl="0">
-              <a:spcBef>
-                <a:spcPts val="0"/>
-              </a:spcBef>
-              <a:spcAft>
-                <a:spcPts val="0"/>
-              </a:spcAft>
-              <a:buNone/>
-            </a:pPr>
-            <a:endParaRPr/>
-          </a:p>
-        </p:txBody>
-      </p:sp>
-      <p:sp>
-        <p:nvSpPr>
-          <p:cNvPr id="52" name="Google Shape;52;p2:notes"/>
+          <p:cNvPr id="2" name="슬라이드 이미지 개체 틀 1"/>
           <p:cNvSpPr>
             <a:spLocks noGrp="1" noRot="1" noChangeAspect="1"/>
           </p:cNvSpPr>
           <p:nvPr>
-            <p:ph type="sldImg" idx="2"/>
+            <p:ph type="sldImg"/>
           </p:nvPr>
         </p:nvSpPr>
         <p:spPr>
@@ -1816,36 +1783,31 @@
             <a:off x="381000" y="685800"/>
             <a:ext cx="6096000" cy="3429000"/>
           </a:xfrm>
-          <a:custGeom>
-            <a:avLst/>
-            <a:gdLst/>
-            <a:ahLst/>
-            <a:cxnLst/>
-            <a:rect l="l" t="t" r="r" b="b"/>
-            <a:pathLst>
-              <a:path w="120000" h="120000" extrusionOk="0">
-                <a:moveTo>
-                  <a:pt x="0" y="0"/>
-                </a:moveTo>
-                <a:lnTo>
-                  <a:pt x="120000" y="0"/>
-                </a:lnTo>
-                <a:lnTo>
-                  <a:pt x="120000" y="120000"/>
-                </a:lnTo>
-                <a:lnTo>
-                  <a:pt x="0" y="120000"/>
-                </a:lnTo>
-                <a:close/>
-              </a:path>
-            </a:pathLst>
-          </a:custGeom>
         </p:spPr>
+      </p:sp>
+      <p:sp>
+        <p:nvSpPr>
+          <p:cNvPr id="3" name="슬라이드 노트 개체 틀 2"/>
+          <p:cNvSpPr>
+            <a:spLocks noGrp="1"/>
+          </p:cNvSpPr>
+          <p:nvPr>
+            <p:ph type="body" idx="1"/>
+          </p:nvPr>
+        </p:nvSpPr>
+        <p:spPr/>
+        <p:txBody>
+          <a:bodyPr/>
+          <a:lstStyle/>
+          <a:p>
+            <a:endParaRPr lang="ko-KR" altLang="en-US" dirty="0"/>
+          </a:p>
+        </p:txBody>
       </p:sp>
     </p:spTree>
     <p:extLst>
       <p:ext uri="{BB962C8B-B14F-4D97-AF65-F5344CB8AC3E}">
-        <p14:creationId xmlns:p14="http://schemas.microsoft.com/office/powerpoint/2010/main" val="2440206250"/>
+        <p14:creationId xmlns:p14="http://schemas.microsoft.com/office/powerpoint/2010/main" val="1595947576"/>
       </p:ext>
     </p:extLst>
   </p:cSld>
@@ -1954,7 +1916,7 @@
     </p:spTree>
     <p:extLst>
       <p:ext uri="{BB962C8B-B14F-4D97-AF65-F5344CB8AC3E}">
-        <p14:creationId xmlns:p14="http://schemas.microsoft.com/office/powerpoint/2010/main" val="235167166"/>
+        <p14:creationId xmlns:p14="http://schemas.microsoft.com/office/powerpoint/2010/main" val="2440206250"/>
       </p:ext>
     </p:extLst>
   </p:cSld>
@@ -4094,31 +4056,6 @@
 </p:sldLayout>
 </file>
 
-<file path=ppt/slideLayouts/slideLayout4.xml><?xml version="1.0" encoding="utf-8"?>
-<p:sldLayout xmlns:a="http://schemas.openxmlformats.org/drawingml/2006/main" xmlns:r="http://schemas.openxmlformats.org/officeDocument/2006/relationships" xmlns:p="http://schemas.openxmlformats.org/presentationml/2006/main" matchingName="1_사용자 지정 레이아웃">
-  <p:cSld name="1_사용자 지정 레이아웃">
-    <p:spTree>
-      <p:nvGrpSpPr>
-        <p:cNvPr id="1" name="Shape 41"/>
-        <p:cNvGrpSpPr/>
-        <p:nvPr/>
-      </p:nvGrpSpPr>
-      <p:grpSpPr>
-        <a:xfrm>
-          <a:off x="0" y="0"/>
-          <a:ext cx="0" cy="0"/>
-          <a:chOff x="0" y="0"/>
-          <a:chExt cx="0" cy="0"/>
-        </a:xfrm>
-      </p:grpSpPr>
-    </p:spTree>
-  </p:cSld>
-  <p:clrMapOvr>
-    <a:masterClrMapping/>
-  </p:clrMapOvr>
-</p:sldLayout>
-</file>
-
 <file path=ppt/slideMasters/slideMaster1.xml><?xml version="1.0" encoding="utf-8"?>
 <p:sldMaster xmlns:a="http://schemas.openxmlformats.org/drawingml/2006/main" xmlns:r="http://schemas.openxmlformats.org/officeDocument/2006/relationships" xmlns:p="http://schemas.openxmlformats.org/presentationml/2006/main">
   <p:cSld>
@@ -5159,7 +5096,6 @@
     <p:sldLayoutId id="2147483649" r:id="rId1"/>
     <p:sldLayoutId id="2147483650" r:id="rId2"/>
     <p:sldLayoutId id="2147483651" r:id="rId3"/>
-    <p:sldLayoutId id="2147483652" r:id="rId4"/>
   </p:sldLayoutIdLst>
   <p:hf sldNum="0" hdr="0" ftr="0" dt="0"/>
   <p:txStyles>
@@ -6273,7 +6209,7 @@
             </a:r>
             <a:r>
               <a:rPr lang="en-US" altLang="ko-KR" sz="2000" dirty="0" err="1"/>
-              <a:t>FiledBackedShell</a:t>
+              <a:t>FileBackedShell</a:t>
             </a:r>
             <a:r>
               <a:rPr lang="ko-KR" altLang="en-US" sz="2000" dirty="0"/>
@@ -7023,13 +6959,12 @@
               <a:rPr lang="ko-KR" altLang="en-US" sz="2000" dirty="0"/>
               <a:t>본문에 명시</a:t>
             </a:r>
-            <a:endParaRPr lang="en-US" altLang="ko-KR" sz="2000" dirty="0"/>
-          </a:p>
-          <a:p>
-            <a:pPr lvl="1"/>
-            <a:r>
+            <a:br>
               <a:rPr lang="en-US" altLang="ko-KR" sz="2000" dirty="0"/>
-              <a:t>TDD </a:t>
+            </a:br>
+            <a:r>
+              <a:rPr lang="en-US" altLang="ko-KR" sz="2000" dirty="0"/>
+              <a:t>    TDD </a:t>
             </a:r>
             <a:r>
               <a:rPr lang="ko-KR" altLang="en-US" sz="2000" dirty="0"/>
@@ -7863,15 +7798,7 @@
             </a:pPr>
             <a:r>
               <a:rPr lang="en-US" altLang="ko-KR" sz="2000" b="1" dirty="0"/>
-              <a:t>PR #69 — Feature/checker/pr4 declare define scope model</a:t>
-            </a:r>
-            <a:r>
-              <a:rPr lang="ko-KR" altLang="en-US" sz="2000" b="1" dirty="0"/>
-              <a:t>　</a:t>
-            </a:r>
-            <a:r>
-              <a:rPr lang="en-US" altLang="ko-KR" sz="2000" b="1" dirty="0"/>
-              <a:t>(</a:t>
+              <a:t>PR #69 — Feature/checker/pr4 declare define scope model (</a:t>
             </a:r>
             <a:r>
               <a:rPr lang="ko-KR" altLang="en-US" sz="2000" b="1" dirty="0"/>
@@ -8060,52 +7987,6 @@
               <a:t>를 스스로 인지하고 안전장치 추가</a:t>
             </a:r>
             <a:endParaRPr lang="en-US" altLang="ko-KR" sz="1800" dirty="0"/>
-          </a:p>
-          <a:p>
-            <a:pPr lvl="1">
-              <a:lnSpc>
-                <a:spcPct val="100000"/>
-              </a:lnSpc>
-            </a:pPr>
-            <a:r>
-              <a:rPr lang="en-US" altLang="ko-KR" sz="1800" dirty="0"/>
-              <a:t>declare/define</a:t>
-            </a:r>
-            <a:r>
-              <a:rPr lang="ko-KR" altLang="en-US" sz="1800" dirty="0"/>
-              <a:t>을 직접 호출하던 </a:t>
-            </a:r>
-            <a:r>
-              <a:rPr lang="ko-KR" altLang="en-US" sz="1800" dirty="0" err="1"/>
-              <a:t>저수준</a:t>
-            </a:r>
-            <a:r>
-              <a:rPr lang="ko-KR" altLang="en-US" sz="1800" dirty="0"/>
-              <a:t> 테스트를 제거하고</a:t>
-            </a:r>
-            <a:r>
-              <a:rPr lang="en-US" altLang="ko-KR" sz="1800" dirty="0"/>
-              <a:t>,</a:t>
-            </a:r>
-            <a:br>
-              <a:rPr lang="en-US" altLang="ko-KR" sz="1800" dirty="0"/>
-            </a:br>
-            <a:r>
-              <a:rPr lang="en-US" altLang="ko-KR" sz="1800" dirty="0"/>
-              <a:t>define </a:t>
-            </a:r>
-            <a:r>
-              <a:rPr lang="ko-KR" altLang="en-US" sz="1800" dirty="0"/>
-              <a:t>누락 시나리오를 커버하는 새 테스트로 교체 → </a:t>
-            </a:r>
-            <a:r>
-              <a:rPr lang="en-US" altLang="ko-KR" sz="1800" dirty="0"/>
-              <a:t>regression </a:t>
-            </a:r>
-            <a:r>
-              <a:rPr lang="ko-KR" altLang="en-US" sz="1800" dirty="0"/>
-              <a:t>방지</a:t>
-            </a:r>
           </a:p>
         </p:txBody>
       </p:sp>
@@ -10201,7 +10082,7 @@
           <a:p>
             <a:r>
               <a:rPr lang="ko-KR" altLang="en-US" sz="2000" dirty="0"/>
-              <a:t>원활한 시연을 위해 텍스트 파일 모드로 실행</a:t>
+              <a:t>원활한 시연을 위해 텍스트 파일 모드로 실행하는 스크립트 활용</a:t>
             </a:r>
             <a:endParaRPr lang="en-US" altLang="ko-KR" sz="2000" dirty="0"/>
           </a:p>
@@ -10363,7 +10244,7 @@
   <p:cSld>
     <p:spTree>
       <p:nvGrpSpPr>
-        <p:cNvPr id="1" name="Shape 64"/>
+        <p:cNvPr id="1" name=""/>
         <p:cNvGrpSpPr/>
         <p:nvPr/>
       </p:nvGrpSpPr>
@@ -10375,7 +10256,57 @@
           <a:chExt cx="0" cy="0"/>
         </a:xfrm>
       </p:grpSpPr>
+      <p:sp>
+        <p:nvSpPr>
+          <p:cNvPr id="2" name="텍스트 개체 틀 1">
+            <a:extLst>
+              <a:ext uri="{FF2B5EF4-FFF2-40B4-BE49-F238E27FC236}">
+                <a16:creationId xmlns:a16="http://schemas.microsoft.com/office/drawing/2014/main" id="{7B14BB02-AE0C-4BB9-A25E-58FA5EF6EEBD}"/>
+              </a:ext>
+            </a:extLst>
+          </p:cNvPr>
+          <p:cNvSpPr>
+            <a:spLocks noGrp="1"/>
+          </p:cNvSpPr>
+          <p:nvPr>
+            <p:ph type="body" idx="1"/>
+          </p:nvPr>
+        </p:nvSpPr>
+        <p:spPr/>
+        <p:txBody>
+          <a:bodyPr/>
+          <a:lstStyle/>
+          <a:p>
+            <a:r>
+              <a:rPr lang="en-US" altLang="ko-KR" dirty="0"/>
+              <a:t>Blameless </a:t>
+            </a:r>
+            <a:r>
+              <a:rPr lang="ko-KR" altLang="en-US" dirty="0"/>
+              <a:t>팀 발표를 </a:t>
+            </a:r>
+            <a:r>
+              <a:rPr lang="ko-KR" altLang="en-US" dirty="0" err="1"/>
+              <a:t>들어주셔서</a:t>
+            </a:r>
+            <a:r>
+              <a:rPr lang="ko-KR" altLang="en-US" dirty="0"/>
+              <a:t> 감사합니다</a:t>
+            </a:r>
+            <a:r>
+              <a:rPr lang="en-US" altLang="ko-KR" dirty="0"/>
+              <a:t>.</a:t>
+            </a:r>
+            <a:endParaRPr lang="ko-KR" altLang="en-US" dirty="0"/>
+          </a:p>
+        </p:txBody>
+      </p:sp>
     </p:spTree>
+    <p:extLst>
+      <p:ext uri="{BB962C8B-B14F-4D97-AF65-F5344CB8AC3E}">
+        <p14:creationId xmlns:p14="http://schemas.microsoft.com/office/powerpoint/2010/main" val="3080307868"/>
+      </p:ext>
+    </p:extLst>
   </p:cSld>
   <p:clrMapOvr>
     <a:masterClrMapping/>
@@ -16296,7 +16227,7 @@
             </a:r>
             <a:r>
               <a:rPr lang="ko-KR" altLang="en-US" dirty="0"/>
-              <a:t>에서는 모드에</a:t>
+              <a:t>에서는 입력 모드에</a:t>
             </a:r>
             <a:r>
               <a:rPr lang="en-US" altLang="ko-KR" dirty="0"/>
@@ -16456,7 +16387,6 @@
               <a:rPr lang="ko-KR" altLang="en-US" dirty="0"/>
               <a:t>구조와 동작 방식을 서로 분리하여 노드의 수정없이 기능 추가 가능</a:t>
             </a:r>
-            <a:endParaRPr lang="en-US" altLang="ko-KR" dirty="0"/>
           </a:p>
           <a:p>
             <a:r>

</xml_diff>